<commit_message>
feat: bilingual assets and investor decks
</commit_message>
<xml_diff>
--- a/reports/investor_deck.pptx
+++ b/reports/investor_deck.pptx
@@ -85,7 +85,61 @@
       </p:grpSpPr>
       <p:sp>
         <p:nvSpPr>
-          <p:cNvPr id="2" name="Title"/>
+          <p:cNvPr id="2" name="Background"/>
+          <p:cNvSpPr/>
+          <p:nvPr/>
+        </p:nvSpPr>
+        <p:spPr>
+          <a:xfrm>
+            <a:off x="0" y="0"/>
+            <a:ext cx="9144000" cy="5143500"/>
+          </a:xfrm>
+          <a:prstGeom prst="rect">
+            <a:avLst/>
+          </a:prstGeom>
+          <a:solidFill>
+            <a:srgbClr val="0F172A"/>
+          </a:solidFill>
+          <a:ln>
+            <a:noFill/>
+          </a:ln>
+        </p:spPr>
+        <p:txBody>
+          <a:bodyPr/>
+          <a:lstStyle/>
+          <a:p/>
+        </p:txBody>
+      </p:sp>
+      <p:sp>
+        <p:nvSpPr>
+          <p:cNvPr id="3" name="Accent"/>
+          <p:cNvSpPr/>
+          <p:nvPr/>
+        </p:nvSpPr>
+        <p:spPr>
+          <a:xfrm>
+            <a:off x="0" y="0"/>
+            <a:ext cx="9144000" cy="120000"/>
+          </a:xfrm>
+          <a:prstGeom prst="rect">
+            <a:avLst/>
+          </a:prstGeom>
+          <a:solidFill>
+            <a:srgbClr val="22D3EE"/>
+          </a:solidFill>
+          <a:ln>
+            <a:noFill/>
+          </a:ln>
+        </p:spPr>
+        <p:txBody>
+          <a:bodyPr/>
+          <a:lstStyle/>
+          <a:p/>
+        </p:txBody>
+      </p:sp>
+      <p:sp>
+        <p:nvSpPr>
+          <p:cNvPr id="4" name="Title"/>
           <p:cNvSpPr txBox="1"/>
           <p:nvPr/>
         </p:nvSpPr>
@@ -106,7 +160,11 @@
               <a:buNone/>
             </a:pPr>
             <a:r>
-              <a:rPr sz="3600" b="1"/>
+              <a:rPr sz="3600" b="1">
+                <a:solidFill>
+                  <a:srgbClr val="7DD3FC"/>
+                </a:solidFill>
+              </a:rPr>
               <a:t>MertFormer Titan</a:t>
             </a:r>
             <a:endParaRPr sz="3600"/>
@@ -115,28 +173,32 @@
       </p:sp>
       <p:sp>
         <p:nvSpPr>
-          <p:cNvPr id="3" name="Body"/>
-          <p:cNvSpPr txBox="1"/>
-          <p:nvPr/>
-        </p:nvSpPr>
-        <p:spPr>
-          <a:xfrm>
-            <a:off x="685800" y="1143000"/>
-            <a:ext cx="7772400" cy="3429000"/>
-          </a:xfrm>
-          <a:prstGeom prst="rect">
-            <a:avLst/>
-          </a:prstGeom>
-        </p:spPr>
-        <p:txBody>
-          <a:bodyPr wrap="square"/>
-          <a:lstStyle/>
-          <a:p>
-            <a:pPr>
-              <a:buChar char="•"/>
-            </a:pPr>
-            <a:r>
-              <a:rPr sz="2400"/>
+          <p:cNvPr id="5" name="Body"/>
+          <p:cNvSpPr txBox="1"/>
+          <p:nvPr/>
+        </p:nvSpPr>
+        <p:spPr>
+          <a:xfrm>
+            <a:off x="685800" y="1200000"/>
+            <a:ext cx="7772400" cy="3200000"/>
+          </a:xfrm>
+          <a:prstGeom prst="rect">
+            <a:avLst/>
+          </a:prstGeom>
+        </p:spPr>
+        <p:txBody>
+          <a:bodyPr wrap="square"/>
+          <a:lstStyle/>
+          <a:p>
+            <a:pPr>
+              <a:buChar char="•"/>
+            </a:pPr>
+            <a:r>
+              <a:rPr sz="2400">
+                <a:solidFill>
+                  <a:srgbClr val="E2E8F0"/>
+                </a:solidFill>
+              </a:rPr>
               <a:t>Edge-native coding model (2.6B target)</a:t>
             </a:r>
             <a:endParaRPr sz="2400"/>
@@ -146,7 +208,11 @@
               <a:buChar char="•"/>
             </a:pPr>
             <a:r>
-              <a:rPr sz="2400"/>
+              <a:rPr sz="2400">
+                <a:solidFill>
+                  <a:srgbClr val="E2E8F0"/>
+                </a:solidFill>
+              </a:rPr>
               <a:t>Operator-mode verified pipeline</a:t>
             </a:r>
             <a:endParaRPr sz="2400"/>
@@ -156,10 +222,48 @@
               <a:buChar char="•"/>
             </a:pPr>
             <a:r>
-              <a:rPr sz="2400"/>
+              <a:rPr sz="2400">
+                <a:solidFill>
+                  <a:srgbClr val="E2E8F0"/>
+                </a:solidFill>
+              </a:rPr>
               <a:t>Offline-first, mobile compute focus</a:t>
             </a:r>
             <a:endParaRPr sz="2400"/>
+          </a:p>
+        </p:txBody>
+      </p:sp>
+      <p:sp>
+        <p:nvSpPr>
+          <p:cNvPr id="6" name="Footer"/>
+          <p:cNvSpPr txBox="1"/>
+          <p:nvPr/>
+        </p:nvSpPr>
+        <p:spPr>
+          <a:xfrm>
+            <a:off x="457200" y="4700000"/>
+            <a:ext cx="8229600" cy="300000"/>
+          </a:xfrm>
+          <a:prstGeom prst="rect">
+            <a:avLst/>
+          </a:prstGeom>
+        </p:spPr>
+        <p:txBody>
+          <a:bodyPr wrap="square"/>
+          <a:lstStyle/>
+          <a:p>
+            <a:pPr>
+              <a:buNone/>
+            </a:pPr>
+            <a:r>
+              <a:rPr sz="1400">
+                <a:solidFill>
+                  <a:srgbClr val="94A3B8"/>
+                </a:solidFill>
+              </a:rPr>
+              <a:t>Confidential — MertFormer Titan</a:t>
+            </a:r>
+            <a:endParaRPr sz="1400"/>
           </a:p>
         </p:txBody>
       </p:sp>
@@ -188,7 +292,61 @@
       </p:grpSpPr>
       <p:sp>
         <p:nvSpPr>
-          <p:cNvPr id="2" name="Title"/>
+          <p:cNvPr id="2" name="Background"/>
+          <p:cNvSpPr/>
+          <p:nvPr/>
+        </p:nvSpPr>
+        <p:spPr>
+          <a:xfrm>
+            <a:off x="0" y="0"/>
+            <a:ext cx="9144000" cy="5143500"/>
+          </a:xfrm>
+          <a:prstGeom prst="rect">
+            <a:avLst/>
+          </a:prstGeom>
+          <a:solidFill>
+            <a:srgbClr val="0F172A"/>
+          </a:solidFill>
+          <a:ln>
+            <a:noFill/>
+          </a:ln>
+        </p:spPr>
+        <p:txBody>
+          <a:bodyPr/>
+          <a:lstStyle/>
+          <a:p/>
+        </p:txBody>
+      </p:sp>
+      <p:sp>
+        <p:nvSpPr>
+          <p:cNvPr id="3" name="Accent"/>
+          <p:cNvSpPr/>
+          <p:nvPr/>
+        </p:nvSpPr>
+        <p:spPr>
+          <a:xfrm>
+            <a:off x="0" y="0"/>
+            <a:ext cx="9144000" cy="120000"/>
+          </a:xfrm>
+          <a:prstGeom prst="rect">
+            <a:avLst/>
+          </a:prstGeom>
+          <a:solidFill>
+            <a:srgbClr val="22D3EE"/>
+          </a:solidFill>
+          <a:ln>
+            <a:noFill/>
+          </a:ln>
+        </p:spPr>
+        <p:txBody>
+          <a:bodyPr/>
+          <a:lstStyle/>
+          <a:p/>
+        </p:txBody>
+      </p:sp>
+      <p:sp>
+        <p:nvSpPr>
+          <p:cNvPr id="4" name="Title"/>
           <p:cNvSpPr txBox="1"/>
           <p:nvPr/>
         </p:nvSpPr>
@@ -209,7 +367,11 @@
               <a:buNone/>
             </a:pPr>
             <a:r>
-              <a:rPr sz="3600" b="1"/>
+              <a:rPr sz="3600" b="1">
+                <a:solidFill>
+                  <a:srgbClr val="7DD3FC"/>
+                </a:solidFill>
+              </a:rPr>
               <a:t>Ask</a:t>
             </a:r>
             <a:endParaRPr sz="3600"/>
@@ -218,28 +380,32 @@
       </p:sp>
       <p:sp>
         <p:nvSpPr>
-          <p:cNvPr id="3" name="Body"/>
-          <p:cNvSpPr txBox="1"/>
-          <p:nvPr/>
-        </p:nvSpPr>
-        <p:spPr>
-          <a:xfrm>
-            <a:off x="685800" y="1143000"/>
-            <a:ext cx="7772400" cy="3429000"/>
-          </a:xfrm>
-          <a:prstGeom prst="rect">
-            <a:avLst/>
-          </a:prstGeom>
-        </p:spPr>
-        <p:txBody>
-          <a:bodyPr wrap="square"/>
-          <a:lstStyle/>
-          <a:p>
-            <a:pPr>
-              <a:buChar char="•"/>
-            </a:pPr>
-            <a:r>
-              <a:rPr sz="2400"/>
+          <p:cNvPr id="5" name="Body"/>
+          <p:cNvSpPr txBox="1"/>
+          <p:nvPr/>
+        </p:nvSpPr>
+        <p:spPr>
+          <a:xfrm>
+            <a:off x="685800" y="1200000"/>
+            <a:ext cx="7772400" cy="3200000"/>
+          </a:xfrm>
+          <a:prstGeom prst="rect">
+            <a:avLst/>
+          </a:prstGeom>
+        </p:spPr>
+        <p:txBody>
+          <a:bodyPr wrap="square"/>
+          <a:lstStyle/>
+          <a:p>
+            <a:pPr>
+              <a:buChar char="•"/>
+            </a:pPr>
+            <a:r>
+              <a:rPr sz="2400">
+                <a:solidFill>
+                  <a:srgbClr val="E2E8F0"/>
+                </a:solidFill>
+              </a:rPr>
               <a:t>Pilot partners for edge coding workflows</a:t>
             </a:r>
             <a:endParaRPr sz="2400"/>
@@ -249,7 +415,11 @@
               <a:buChar char="•"/>
             </a:pPr>
             <a:r>
-              <a:rPr sz="2400"/>
+              <a:rPr sz="2400">
+                <a:solidFill>
+                  <a:srgbClr val="E2E8F0"/>
+                </a:solidFill>
+              </a:rPr>
               <a:t>Infrastructure credits for training runs</a:t>
             </a:r>
             <a:endParaRPr sz="2400"/>
@@ -259,10 +429,48 @@
               <a:buChar char="•"/>
             </a:pPr>
             <a:r>
-              <a:rPr sz="2400"/>
+              <a:rPr sz="2400">
+                <a:solidFill>
+                  <a:srgbClr val="E2E8F0"/>
+                </a:solidFill>
+              </a:rPr>
               <a:t>Strategic advisors for deployment validation</a:t>
             </a:r>
             <a:endParaRPr sz="2400"/>
+          </a:p>
+        </p:txBody>
+      </p:sp>
+      <p:sp>
+        <p:nvSpPr>
+          <p:cNvPr id="6" name="Footer"/>
+          <p:cNvSpPr txBox="1"/>
+          <p:nvPr/>
+        </p:nvSpPr>
+        <p:spPr>
+          <a:xfrm>
+            <a:off x="457200" y="4700000"/>
+            <a:ext cx="8229600" cy="300000"/>
+          </a:xfrm>
+          <a:prstGeom prst="rect">
+            <a:avLst/>
+          </a:prstGeom>
+        </p:spPr>
+        <p:txBody>
+          <a:bodyPr wrap="square"/>
+          <a:lstStyle/>
+          <a:p>
+            <a:pPr>
+              <a:buNone/>
+            </a:pPr>
+            <a:r>
+              <a:rPr sz="1400">
+                <a:solidFill>
+                  <a:srgbClr val="94A3B8"/>
+                </a:solidFill>
+              </a:rPr>
+              <a:t>Confidential — MertFormer Titan</a:t>
+            </a:r>
+            <a:endParaRPr sz="1400"/>
           </a:p>
         </p:txBody>
       </p:sp>
@@ -291,7 +499,61 @@
       </p:grpSpPr>
       <p:sp>
         <p:nvSpPr>
-          <p:cNvPr id="2" name="Title"/>
+          <p:cNvPr id="2" name="Background"/>
+          <p:cNvSpPr/>
+          <p:nvPr/>
+        </p:nvSpPr>
+        <p:spPr>
+          <a:xfrm>
+            <a:off x="0" y="0"/>
+            <a:ext cx="9144000" cy="5143500"/>
+          </a:xfrm>
+          <a:prstGeom prst="rect">
+            <a:avLst/>
+          </a:prstGeom>
+          <a:solidFill>
+            <a:srgbClr val="0F172A"/>
+          </a:solidFill>
+          <a:ln>
+            <a:noFill/>
+          </a:ln>
+        </p:spPr>
+        <p:txBody>
+          <a:bodyPr/>
+          <a:lstStyle/>
+          <a:p/>
+        </p:txBody>
+      </p:sp>
+      <p:sp>
+        <p:nvSpPr>
+          <p:cNvPr id="3" name="Accent"/>
+          <p:cNvSpPr/>
+          <p:nvPr/>
+        </p:nvSpPr>
+        <p:spPr>
+          <a:xfrm>
+            <a:off x="0" y="0"/>
+            <a:ext cx="9144000" cy="120000"/>
+          </a:xfrm>
+          <a:prstGeom prst="rect">
+            <a:avLst/>
+          </a:prstGeom>
+          <a:solidFill>
+            <a:srgbClr val="22D3EE"/>
+          </a:solidFill>
+          <a:ln>
+            <a:noFill/>
+          </a:ln>
+        </p:spPr>
+        <p:txBody>
+          <a:bodyPr/>
+          <a:lstStyle/>
+          <a:p/>
+        </p:txBody>
+      </p:sp>
+      <p:sp>
+        <p:nvSpPr>
+          <p:cNvPr id="4" name="Title"/>
           <p:cNvSpPr txBox="1"/>
           <p:nvPr/>
         </p:nvSpPr>
@@ -312,7 +574,11 @@
               <a:buNone/>
             </a:pPr>
             <a:r>
-              <a:rPr sz="3600" b="1"/>
+              <a:rPr sz="3600" b="1">
+                <a:solidFill>
+                  <a:srgbClr val="7DD3FC"/>
+                </a:solidFill>
+              </a:rPr>
               <a:t>Problem</a:t>
             </a:r>
             <a:endParaRPr sz="3600"/>
@@ -321,28 +587,32 @@
       </p:sp>
       <p:sp>
         <p:nvSpPr>
-          <p:cNvPr id="3" name="Body"/>
-          <p:cNvSpPr txBox="1"/>
-          <p:nvPr/>
-        </p:nvSpPr>
-        <p:spPr>
-          <a:xfrm>
-            <a:off x="685800" y="1143000"/>
-            <a:ext cx="7772400" cy="3429000"/>
-          </a:xfrm>
-          <a:prstGeom prst="rect">
-            <a:avLst/>
-          </a:prstGeom>
-        </p:spPr>
-        <p:txBody>
-          <a:bodyPr wrap="square"/>
-          <a:lstStyle/>
-          <a:p>
-            <a:pPr>
-              <a:buChar char="•"/>
-            </a:pPr>
-            <a:r>
-              <a:rPr sz="2400"/>
+          <p:cNvPr id="5" name="Body"/>
+          <p:cNvSpPr txBox="1"/>
+          <p:nvPr/>
+        </p:nvSpPr>
+        <p:spPr>
+          <a:xfrm>
+            <a:off x="685800" y="1200000"/>
+            <a:ext cx="7772400" cy="3200000"/>
+          </a:xfrm>
+          <a:prstGeom prst="rect">
+            <a:avLst/>
+          </a:prstGeom>
+        </p:spPr>
+        <p:txBody>
+          <a:bodyPr wrap="square"/>
+          <a:lstStyle/>
+          <a:p>
+            <a:pPr>
+              <a:buChar char="•"/>
+            </a:pPr>
+            <a:r>
+              <a:rPr sz="2400">
+                <a:solidFill>
+                  <a:srgbClr val="E2E8F0"/>
+                </a:solidFill>
+              </a:rPr>
               <a:t>Cloud AI is costly and slow for regulated workflows</a:t>
             </a:r>
             <a:endParaRPr sz="2400"/>
@@ -352,7 +622,11 @@
               <a:buChar char="•"/>
             </a:pPr>
             <a:r>
-              <a:rPr sz="2400"/>
+              <a:rPr sz="2400">
+                <a:solidFill>
+                  <a:srgbClr val="E2E8F0"/>
+                </a:solidFill>
+              </a:rPr>
               <a:t>Privacy and data sovereignty are hard to guarantee</a:t>
             </a:r>
             <a:endParaRPr sz="2400"/>
@@ -362,10 +636,48 @@
               <a:buChar char="•"/>
             </a:pPr>
             <a:r>
-              <a:rPr sz="2400"/>
+              <a:rPr sz="2400">
+                <a:solidFill>
+                  <a:srgbClr val="E2E8F0"/>
+                </a:solidFill>
+              </a:rPr>
               <a:t>Latency blocks real-time, on-device coding</a:t>
             </a:r>
             <a:endParaRPr sz="2400"/>
+          </a:p>
+        </p:txBody>
+      </p:sp>
+      <p:sp>
+        <p:nvSpPr>
+          <p:cNvPr id="6" name="Footer"/>
+          <p:cNvSpPr txBox="1"/>
+          <p:nvPr/>
+        </p:nvSpPr>
+        <p:spPr>
+          <a:xfrm>
+            <a:off x="457200" y="4700000"/>
+            <a:ext cx="8229600" cy="300000"/>
+          </a:xfrm>
+          <a:prstGeom prst="rect">
+            <a:avLst/>
+          </a:prstGeom>
+        </p:spPr>
+        <p:txBody>
+          <a:bodyPr wrap="square"/>
+          <a:lstStyle/>
+          <a:p>
+            <a:pPr>
+              <a:buNone/>
+            </a:pPr>
+            <a:r>
+              <a:rPr sz="1400">
+                <a:solidFill>
+                  <a:srgbClr val="94A3B8"/>
+                </a:solidFill>
+              </a:rPr>
+              <a:t>Confidential — MertFormer Titan</a:t>
+            </a:r>
+            <a:endParaRPr sz="1400"/>
           </a:p>
         </p:txBody>
       </p:sp>
@@ -394,7 +706,61 @@
       </p:grpSpPr>
       <p:sp>
         <p:nvSpPr>
-          <p:cNvPr id="2" name="Title"/>
+          <p:cNvPr id="2" name="Background"/>
+          <p:cNvSpPr/>
+          <p:nvPr/>
+        </p:nvSpPr>
+        <p:spPr>
+          <a:xfrm>
+            <a:off x="0" y="0"/>
+            <a:ext cx="9144000" cy="5143500"/>
+          </a:xfrm>
+          <a:prstGeom prst="rect">
+            <a:avLst/>
+          </a:prstGeom>
+          <a:solidFill>
+            <a:srgbClr val="0F172A"/>
+          </a:solidFill>
+          <a:ln>
+            <a:noFill/>
+          </a:ln>
+        </p:spPr>
+        <p:txBody>
+          <a:bodyPr/>
+          <a:lstStyle/>
+          <a:p/>
+        </p:txBody>
+      </p:sp>
+      <p:sp>
+        <p:nvSpPr>
+          <p:cNvPr id="3" name="Accent"/>
+          <p:cNvSpPr/>
+          <p:nvPr/>
+        </p:nvSpPr>
+        <p:spPr>
+          <a:xfrm>
+            <a:off x="0" y="0"/>
+            <a:ext cx="9144000" cy="120000"/>
+          </a:xfrm>
+          <a:prstGeom prst="rect">
+            <a:avLst/>
+          </a:prstGeom>
+          <a:solidFill>
+            <a:srgbClr val="22D3EE"/>
+          </a:solidFill>
+          <a:ln>
+            <a:noFill/>
+          </a:ln>
+        </p:spPr>
+        <p:txBody>
+          <a:bodyPr/>
+          <a:lstStyle/>
+          <a:p/>
+        </p:txBody>
+      </p:sp>
+      <p:sp>
+        <p:nvSpPr>
+          <p:cNvPr id="4" name="Title"/>
           <p:cNvSpPr txBox="1"/>
           <p:nvPr/>
         </p:nvSpPr>
@@ -415,7 +781,11 @@
               <a:buNone/>
             </a:pPr>
             <a:r>
-              <a:rPr sz="3600" b="1"/>
+              <a:rPr sz="3600" b="1">
+                <a:solidFill>
+                  <a:srgbClr val="7DD3FC"/>
+                </a:solidFill>
+              </a:rPr>
               <a:t>Solution</a:t>
             </a:r>
             <a:endParaRPr sz="3600"/>
@@ -424,28 +794,32 @@
       </p:sp>
       <p:sp>
         <p:nvSpPr>
-          <p:cNvPr id="3" name="Body"/>
-          <p:cNvSpPr txBox="1"/>
-          <p:nvPr/>
-        </p:nvSpPr>
-        <p:spPr>
-          <a:xfrm>
-            <a:off x="685800" y="1143000"/>
-            <a:ext cx="7772400" cy="3429000"/>
-          </a:xfrm>
-          <a:prstGeom prst="rect">
-            <a:avLst/>
-          </a:prstGeom>
-        </p:spPr>
-        <p:txBody>
-          <a:bodyPr wrap="square"/>
-          <a:lstStyle/>
-          <a:p>
-            <a:pPr>
-              <a:buChar char="•"/>
-            </a:pPr>
-            <a:r>
-              <a:rPr sz="2400"/>
+          <p:cNvPr id="5" name="Body"/>
+          <p:cNvSpPr txBox="1"/>
+          <p:nvPr/>
+        </p:nvSpPr>
+        <p:spPr>
+          <a:xfrm>
+            <a:off x="685800" y="1200000"/>
+            <a:ext cx="7772400" cy="3200000"/>
+          </a:xfrm>
+          <a:prstGeom prst="rect">
+            <a:avLst/>
+          </a:prstGeom>
+        </p:spPr>
+        <p:txBody>
+          <a:bodyPr wrap="square"/>
+          <a:lstStyle/>
+          <a:p>
+            <a:pPr>
+              <a:buChar char="•"/>
+            </a:pPr>
+            <a:r>
+              <a:rPr sz="2400">
+                <a:solidFill>
+                  <a:srgbClr val="E2E8F0"/>
+                </a:solidFill>
+              </a:rPr>
               <a:t>On-device inference with BitNet 1.58-bit quantization</a:t>
             </a:r>
             <a:endParaRPr sz="2400"/>
@@ -455,7 +829,11 @@
               <a:buChar char="•"/>
             </a:pPr>
             <a:r>
-              <a:rPr sz="2400"/>
+              <a:rPr sz="2400">
+                <a:solidFill>
+                  <a:srgbClr val="E2E8F0"/>
+                </a:solidFill>
+              </a:rPr>
               <a:t>LiquidRouter MoE for stable, efficient routing</a:t>
             </a:r>
             <a:endParaRPr sz="2400"/>
@@ -465,10 +843,48 @@
               <a:buChar char="•"/>
             </a:pPr>
             <a:r>
-              <a:rPr sz="2400"/>
+              <a:rPr sz="2400">
+                <a:solidFill>
+                  <a:srgbClr val="E2E8F0"/>
+                </a:solidFill>
+              </a:rPr>
               <a:t>Long-context attention optimized for code</a:t>
             </a:r>
             <a:endParaRPr sz="2400"/>
+          </a:p>
+        </p:txBody>
+      </p:sp>
+      <p:sp>
+        <p:nvSpPr>
+          <p:cNvPr id="6" name="Footer"/>
+          <p:cNvSpPr txBox="1"/>
+          <p:nvPr/>
+        </p:nvSpPr>
+        <p:spPr>
+          <a:xfrm>
+            <a:off x="457200" y="4700000"/>
+            <a:ext cx="8229600" cy="300000"/>
+          </a:xfrm>
+          <a:prstGeom prst="rect">
+            <a:avLst/>
+          </a:prstGeom>
+        </p:spPr>
+        <p:txBody>
+          <a:bodyPr wrap="square"/>
+          <a:lstStyle/>
+          <a:p>
+            <a:pPr>
+              <a:buNone/>
+            </a:pPr>
+            <a:r>
+              <a:rPr sz="1400">
+                <a:solidFill>
+                  <a:srgbClr val="94A3B8"/>
+                </a:solidFill>
+              </a:rPr>
+              <a:t>Confidential — MertFormer Titan</a:t>
+            </a:r>
+            <a:endParaRPr sz="1400"/>
           </a:p>
         </p:txBody>
       </p:sp>
@@ -497,7 +913,61 @@
       </p:grpSpPr>
       <p:sp>
         <p:nvSpPr>
-          <p:cNvPr id="2" name="Title"/>
+          <p:cNvPr id="2" name="Background"/>
+          <p:cNvSpPr/>
+          <p:nvPr/>
+        </p:nvSpPr>
+        <p:spPr>
+          <a:xfrm>
+            <a:off x="0" y="0"/>
+            <a:ext cx="9144000" cy="5143500"/>
+          </a:xfrm>
+          <a:prstGeom prst="rect">
+            <a:avLst/>
+          </a:prstGeom>
+          <a:solidFill>
+            <a:srgbClr val="0F172A"/>
+          </a:solidFill>
+          <a:ln>
+            <a:noFill/>
+          </a:ln>
+        </p:spPr>
+        <p:txBody>
+          <a:bodyPr/>
+          <a:lstStyle/>
+          <a:p/>
+        </p:txBody>
+      </p:sp>
+      <p:sp>
+        <p:nvSpPr>
+          <p:cNvPr id="3" name="Accent"/>
+          <p:cNvSpPr/>
+          <p:nvPr/>
+        </p:nvSpPr>
+        <p:spPr>
+          <a:xfrm>
+            <a:off x="0" y="0"/>
+            <a:ext cx="9144000" cy="120000"/>
+          </a:xfrm>
+          <a:prstGeom prst="rect">
+            <a:avLst/>
+          </a:prstGeom>
+          <a:solidFill>
+            <a:srgbClr val="22D3EE"/>
+          </a:solidFill>
+          <a:ln>
+            <a:noFill/>
+          </a:ln>
+        </p:spPr>
+        <p:txBody>
+          <a:bodyPr/>
+          <a:lstStyle/>
+          <a:p/>
+        </p:txBody>
+      </p:sp>
+      <p:sp>
+        <p:nvSpPr>
+          <p:cNvPr id="4" name="Title"/>
           <p:cNvSpPr txBox="1"/>
           <p:nvPr/>
         </p:nvSpPr>
@@ -518,7 +988,11 @@
               <a:buNone/>
             </a:pPr>
             <a:r>
-              <a:rPr sz="3600" b="1"/>
+              <a:rPr sz="3600" b="1">
+                <a:solidFill>
+                  <a:srgbClr val="7DD3FC"/>
+                </a:solidFill>
+              </a:rPr>
               <a:t>Product</a:t>
             </a:r>
             <a:endParaRPr sz="3600"/>
@@ -527,28 +1001,32 @@
       </p:sp>
       <p:sp>
         <p:nvSpPr>
-          <p:cNvPr id="3" name="Body"/>
-          <p:cNvSpPr txBox="1"/>
-          <p:nvPr/>
-        </p:nvSpPr>
-        <p:spPr>
-          <a:xfrm>
-            <a:off x="685800" y="1143000"/>
-            <a:ext cx="7772400" cy="3429000"/>
-          </a:xfrm>
-          <a:prstGeom prst="rect">
-            <a:avLst/>
-          </a:prstGeom>
-        </p:spPr>
-        <p:txBody>
-          <a:bodyPr wrap="square"/>
-          <a:lstStyle/>
-          <a:p>
-            <a:pPr>
-              <a:buChar char="•"/>
-            </a:pPr>
-            <a:r>
-              <a:rPr sz="2400"/>
+          <p:cNvPr id="5" name="Body"/>
+          <p:cNvSpPr txBox="1"/>
+          <p:nvPr/>
+        </p:nvSpPr>
+        <p:spPr>
+          <a:xfrm>
+            <a:off x="685800" y="1200000"/>
+            <a:ext cx="7772400" cy="3200000"/>
+          </a:xfrm>
+          <a:prstGeom prst="rect">
+            <a:avLst/>
+          </a:prstGeom>
+        </p:spPr>
+        <p:txBody>
+          <a:bodyPr wrap="square"/>
+          <a:lstStyle/>
+          <a:p>
+            <a:pPr>
+              <a:buChar char="•"/>
+            </a:pPr>
+            <a:r>
+              <a:rPr sz="2400">
+                <a:solidFill>
+                  <a:srgbClr val="E2E8F0"/>
+                </a:solidFill>
+              </a:rPr>
               <a:t>2.6B parameter target model for coding</a:t>
             </a:r>
             <a:endParaRPr sz="2400"/>
@@ -558,7 +1036,11 @@
               <a:buChar char="•"/>
             </a:pPr>
             <a:r>
-              <a:rPr sz="2400"/>
+              <a:rPr sz="2400">
+                <a:solidFill>
+                  <a:srgbClr val="E2E8F0"/>
+                </a:solidFill>
+              </a:rPr>
               <a:t>Offline operation on mobile-class hardware</a:t>
             </a:r>
             <a:endParaRPr sz="2400"/>
@@ -568,10 +1050,48 @@
               <a:buChar char="•"/>
             </a:pPr>
             <a:r>
-              <a:rPr sz="2400"/>
+              <a:rPr sz="2400">
+                <a:solidFill>
+                  <a:srgbClr val="E2E8F0"/>
+                </a:solidFill>
+              </a:rPr>
               <a:t>Security-first with reproducibility gates</a:t>
             </a:r>
             <a:endParaRPr sz="2400"/>
+          </a:p>
+        </p:txBody>
+      </p:sp>
+      <p:sp>
+        <p:nvSpPr>
+          <p:cNvPr id="6" name="Footer"/>
+          <p:cNvSpPr txBox="1"/>
+          <p:nvPr/>
+        </p:nvSpPr>
+        <p:spPr>
+          <a:xfrm>
+            <a:off x="457200" y="4700000"/>
+            <a:ext cx="8229600" cy="300000"/>
+          </a:xfrm>
+          <a:prstGeom prst="rect">
+            <a:avLst/>
+          </a:prstGeom>
+        </p:spPr>
+        <p:txBody>
+          <a:bodyPr wrap="square"/>
+          <a:lstStyle/>
+          <a:p>
+            <a:pPr>
+              <a:buNone/>
+            </a:pPr>
+            <a:r>
+              <a:rPr sz="1400">
+                <a:solidFill>
+                  <a:srgbClr val="94A3B8"/>
+                </a:solidFill>
+              </a:rPr>
+              <a:t>Confidential — MertFormer Titan</a:t>
+            </a:r>
+            <a:endParaRPr sz="1400"/>
           </a:p>
         </p:txBody>
       </p:sp>
@@ -600,7 +1120,61 @@
       </p:grpSpPr>
       <p:sp>
         <p:nvSpPr>
-          <p:cNvPr id="2" name="Title"/>
+          <p:cNvPr id="2" name="Background"/>
+          <p:cNvSpPr/>
+          <p:nvPr/>
+        </p:nvSpPr>
+        <p:spPr>
+          <a:xfrm>
+            <a:off x="0" y="0"/>
+            <a:ext cx="9144000" cy="5143500"/>
+          </a:xfrm>
+          <a:prstGeom prst="rect">
+            <a:avLst/>
+          </a:prstGeom>
+          <a:solidFill>
+            <a:srgbClr val="0F172A"/>
+          </a:solidFill>
+          <a:ln>
+            <a:noFill/>
+          </a:ln>
+        </p:spPr>
+        <p:txBody>
+          <a:bodyPr/>
+          <a:lstStyle/>
+          <a:p/>
+        </p:txBody>
+      </p:sp>
+      <p:sp>
+        <p:nvSpPr>
+          <p:cNvPr id="3" name="Accent"/>
+          <p:cNvSpPr/>
+          <p:nvPr/>
+        </p:nvSpPr>
+        <p:spPr>
+          <a:xfrm>
+            <a:off x="0" y="0"/>
+            <a:ext cx="9144000" cy="120000"/>
+          </a:xfrm>
+          <a:prstGeom prst="rect">
+            <a:avLst/>
+          </a:prstGeom>
+          <a:solidFill>
+            <a:srgbClr val="22D3EE"/>
+          </a:solidFill>
+          <a:ln>
+            <a:noFill/>
+          </a:ln>
+        </p:spPr>
+        <p:txBody>
+          <a:bodyPr/>
+          <a:lstStyle/>
+          <a:p/>
+        </p:txBody>
+      </p:sp>
+      <p:sp>
+        <p:nvSpPr>
+          <p:cNvPr id="4" name="Title"/>
           <p:cNvSpPr txBox="1"/>
           <p:nvPr/>
         </p:nvSpPr>
@@ -621,7 +1195,11 @@
               <a:buNone/>
             </a:pPr>
             <a:r>
-              <a:rPr sz="3600" b="1"/>
+              <a:rPr sz="3600" b="1">
+                <a:solidFill>
+                  <a:srgbClr val="7DD3FC"/>
+                </a:solidFill>
+              </a:rPr>
               <a:t>Architecture Highlights</a:t>
             </a:r>
             <a:endParaRPr sz="3600"/>
@@ -630,28 +1208,32 @@
       </p:sp>
       <p:sp>
         <p:nvSpPr>
-          <p:cNvPr id="3" name="Body"/>
-          <p:cNvSpPr txBox="1"/>
-          <p:nvPr/>
-        </p:nvSpPr>
-        <p:spPr>
-          <a:xfrm>
-            <a:off x="685800" y="1143000"/>
-            <a:ext cx="7772400" cy="3429000"/>
-          </a:xfrm>
-          <a:prstGeom prst="rect">
-            <a:avLst/>
-          </a:prstGeom>
-        </p:spPr>
-        <p:txBody>
-          <a:bodyPr wrap="square"/>
-          <a:lstStyle/>
-          <a:p>
-            <a:pPr>
-              <a:buChar char="•"/>
-            </a:pPr>
-            <a:r>
-              <a:rPr sz="2400"/>
+          <p:cNvPr id="5" name="Body"/>
+          <p:cNvSpPr txBox="1"/>
+          <p:nvPr/>
+        </p:nvSpPr>
+        <p:spPr>
+          <a:xfrm>
+            <a:off x="685800" y="1200000"/>
+            <a:ext cx="7772400" cy="3200000"/>
+          </a:xfrm>
+          <a:prstGeom prst="rect">
+            <a:avLst/>
+          </a:prstGeom>
+        </p:spPr>
+        <p:txBody>
+          <a:bodyPr wrap="square"/>
+          <a:lstStyle/>
+          <a:p>
+            <a:pPr>
+              <a:buChar char="•"/>
+            </a:pPr>
+            <a:r>
+              <a:rPr sz="2400">
+                <a:solidFill>
+                  <a:srgbClr val="E2E8F0"/>
+                </a:solidFill>
+              </a:rPr>
               <a:t>BitLinear + Liquid Neural Networks</a:t>
             </a:r>
             <a:endParaRPr sz="2400"/>
@@ -661,7 +1243,11 @@
               <a:buChar char="•"/>
             </a:pPr>
             <a:r>
-              <a:rPr sz="2400"/>
+              <a:rPr sz="2400">
+                <a:solidFill>
+                  <a:srgbClr val="E2E8F0"/>
+                </a:solidFill>
+              </a:rPr>
               <a:t>MLA attention with long-context readiness</a:t>
             </a:r>
             <a:endParaRPr sz="2400"/>
@@ -671,10 +1257,48 @@
               <a:buChar char="•"/>
             </a:pPr>
             <a:r>
-              <a:rPr sz="2400"/>
+              <a:rPr sz="2400">
+                <a:solidFill>
+                  <a:srgbClr val="E2E8F0"/>
+                </a:solidFill>
+              </a:rPr>
               <a:t>Sparse MoE with temporal routing</a:t>
             </a:r>
             <a:endParaRPr sz="2400"/>
+          </a:p>
+        </p:txBody>
+      </p:sp>
+      <p:sp>
+        <p:nvSpPr>
+          <p:cNvPr id="6" name="Footer"/>
+          <p:cNvSpPr txBox="1"/>
+          <p:nvPr/>
+        </p:nvSpPr>
+        <p:spPr>
+          <a:xfrm>
+            <a:off x="457200" y="4700000"/>
+            <a:ext cx="8229600" cy="300000"/>
+          </a:xfrm>
+          <a:prstGeom prst="rect">
+            <a:avLst/>
+          </a:prstGeom>
+        </p:spPr>
+        <p:txBody>
+          <a:bodyPr wrap="square"/>
+          <a:lstStyle/>
+          <a:p>
+            <a:pPr>
+              <a:buNone/>
+            </a:pPr>
+            <a:r>
+              <a:rPr sz="1400">
+                <a:solidFill>
+                  <a:srgbClr val="94A3B8"/>
+                </a:solidFill>
+              </a:rPr>
+              <a:t>Confidential — MertFormer Titan</a:t>
+            </a:r>
+            <a:endParaRPr sz="1400"/>
           </a:p>
         </p:txBody>
       </p:sp>
@@ -703,7 +1327,61 @@
       </p:grpSpPr>
       <p:sp>
         <p:nvSpPr>
-          <p:cNvPr id="2" name="Title"/>
+          <p:cNvPr id="2" name="Background"/>
+          <p:cNvSpPr/>
+          <p:nvPr/>
+        </p:nvSpPr>
+        <p:spPr>
+          <a:xfrm>
+            <a:off x="0" y="0"/>
+            <a:ext cx="9144000" cy="5143500"/>
+          </a:xfrm>
+          <a:prstGeom prst="rect">
+            <a:avLst/>
+          </a:prstGeom>
+          <a:solidFill>
+            <a:srgbClr val="0F172A"/>
+          </a:solidFill>
+          <a:ln>
+            <a:noFill/>
+          </a:ln>
+        </p:spPr>
+        <p:txBody>
+          <a:bodyPr/>
+          <a:lstStyle/>
+          <a:p/>
+        </p:txBody>
+      </p:sp>
+      <p:sp>
+        <p:nvSpPr>
+          <p:cNvPr id="3" name="Accent"/>
+          <p:cNvSpPr/>
+          <p:nvPr/>
+        </p:nvSpPr>
+        <p:spPr>
+          <a:xfrm>
+            <a:off x="0" y="0"/>
+            <a:ext cx="9144000" cy="120000"/>
+          </a:xfrm>
+          <a:prstGeom prst="rect">
+            <a:avLst/>
+          </a:prstGeom>
+          <a:solidFill>
+            <a:srgbClr val="22D3EE"/>
+          </a:solidFill>
+          <a:ln>
+            <a:noFill/>
+          </a:ln>
+        </p:spPr>
+        <p:txBody>
+          <a:bodyPr/>
+          <a:lstStyle/>
+          <a:p/>
+        </p:txBody>
+      </p:sp>
+      <p:sp>
+        <p:nvSpPr>
+          <p:cNvPr id="4" name="Title"/>
           <p:cNvSpPr txBox="1"/>
           <p:nvPr/>
         </p:nvSpPr>
@@ -724,7 +1402,11 @@
               <a:buNone/>
             </a:pPr>
             <a:r>
-              <a:rPr sz="3600" b="1"/>
+              <a:rPr sz="3600" b="1">
+                <a:solidFill>
+                  <a:srgbClr val="7DD3FC"/>
+                </a:solidFill>
+              </a:rPr>
               <a:t>Safety &amp; Reliability</a:t>
             </a:r>
             <a:endParaRPr sz="3600"/>
@@ -733,28 +1415,32 @@
       </p:sp>
       <p:sp>
         <p:nvSpPr>
-          <p:cNvPr id="3" name="Body"/>
-          <p:cNvSpPr txBox="1"/>
-          <p:nvPr/>
-        </p:nvSpPr>
-        <p:spPr>
-          <a:xfrm>
-            <a:off x="685800" y="1143000"/>
-            <a:ext cx="7772400" cy="3429000"/>
-          </a:xfrm>
-          <a:prstGeom prst="rect">
-            <a:avLst/>
-          </a:prstGeom>
-        </p:spPr>
-        <p:txBody>
-          <a:bodyPr wrap="square"/>
-          <a:lstStyle/>
-          <a:p>
-            <a:pPr>
-              <a:buChar char="•"/>
-            </a:pPr>
-            <a:r>
-              <a:rPr sz="2400"/>
+          <p:cNvPr id="5" name="Body"/>
+          <p:cNvSpPr txBox="1"/>
+          <p:nvPr/>
+        </p:nvSpPr>
+        <p:spPr>
+          <a:xfrm>
+            <a:off x="685800" y="1200000"/>
+            <a:ext cx="7772400" cy="3200000"/>
+          </a:xfrm>
+          <a:prstGeom prst="rect">
+            <a:avLst/>
+          </a:prstGeom>
+        </p:spPr>
+        <p:txBody>
+          <a:bodyPr wrap="square"/>
+          <a:lstStyle/>
+          <a:p>
+            <a:pPr>
+              <a:buChar char="•"/>
+            </a:pPr>
+            <a:r>
+              <a:rPr sz="2400">
+                <a:solidFill>
+                  <a:srgbClr val="E2E8F0"/>
+                </a:solidFill>
+              </a:rPr>
               <a:t>Kill-switch for non-finite stability events</a:t>
             </a:r>
             <a:endParaRPr sz="2400"/>
@@ -764,7 +1450,11 @@
               <a:buChar char="•"/>
             </a:pPr>
             <a:r>
-              <a:rPr sz="2400"/>
+              <a:rPr sz="2400">
+                <a:solidFill>
+                  <a:srgbClr val="E2E8F0"/>
+                </a:solidFill>
+              </a:rPr>
               <a:t>Failure budget and pivot triggers</a:t>
             </a:r>
             <a:endParaRPr sz="2400"/>
@@ -774,10 +1464,48 @@
               <a:buChar char="•"/>
             </a:pPr>
             <a:r>
-              <a:rPr sz="2400"/>
+              <a:rPr sz="2400">
+                <a:solidFill>
+                  <a:srgbClr val="E2E8F0"/>
+                </a:solidFill>
+              </a:rPr>
               <a:t>Checkpoint restore drills and reproducibility stamp</a:t>
             </a:r>
             <a:endParaRPr sz="2400"/>
+          </a:p>
+        </p:txBody>
+      </p:sp>
+      <p:sp>
+        <p:nvSpPr>
+          <p:cNvPr id="6" name="Footer"/>
+          <p:cNvSpPr txBox="1"/>
+          <p:nvPr/>
+        </p:nvSpPr>
+        <p:spPr>
+          <a:xfrm>
+            <a:off x="457200" y="4700000"/>
+            <a:ext cx="8229600" cy="300000"/>
+          </a:xfrm>
+          <a:prstGeom prst="rect">
+            <a:avLst/>
+          </a:prstGeom>
+        </p:spPr>
+        <p:txBody>
+          <a:bodyPr wrap="square"/>
+          <a:lstStyle/>
+          <a:p>
+            <a:pPr>
+              <a:buNone/>
+            </a:pPr>
+            <a:r>
+              <a:rPr sz="1400">
+                <a:solidFill>
+                  <a:srgbClr val="94A3B8"/>
+                </a:solidFill>
+              </a:rPr>
+              <a:t>Confidential — MertFormer Titan</a:t>
+            </a:r>
+            <a:endParaRPr sz="1400"/>
           </a:p>
         </p:txBody>
       </p:sp>
@@ -806,7 +1534,61 @@
       </p:grpSpPr>
       <p:sp>
         <p:nvSpPr>
-          <p:cNvPr id="2" name="Title"/>
+          <p:cNvPr id="2" name="Background"/>
+          <p:cNvSpPr/>
+          <p:nvPr/>
+        </p:nvSpPr>
+        <p:spPr>
+          <a:xfrm>
+            <a:off x="0" y="0"/>
+            <a:ext cx="9144000" cy="5143500"/>
+          </a:xfrm>
+          <a:prstGeom prst="rect">
+            <a:avLst/>
+          </a:prstGeom>
+          <a:solidFill>
+            <a:srgbClr val="0F172A"/>
+          </a:solidFill>
+          <a:ln>
+            <a:noFill/>
+          </a:ln>
+        </p:spPr>
+        <p:txBody>
+          <a:bodyPr/>
+          <a:lstStyle/>
+          <a:p/>
+        </p:txBody>
+      </p:sp>
+      <p:sp>
+        <p:nvSpPr>
+          <p:cNvPr id="3" name="Accent"/>
+          <p:cNvSpPr/>
+          <p:nvPr/>
+        </p:nvSpPr>
+        <p:spPr>
+          <a:xfrm>
+            <a:off x="0" y="0"/>
+            <a:ext cx="9144000" cy="120000"/>
+          </a:xfrm>
+          <a:prstGeom prst="rect">
+            <a:avLst/>
+          </a:prstGeom>
+          <a:solidFill>
+            <a:srgbClr val="22D3EE"/>
+          </a:solidFill>
+          <a:ln>
+            <a:noFill/>
+          </a:ln>
+        </p:spPr>
+        <p:txBody>
+          <a:bodyPr/>
+          <a:lstStyle/>
+          <a:p/>
+        </p:txBody>
+      </p:sp>
+      <p:sp>
+        <p:nvSpPr>
+          <p:cNvPr id="4" name="Title"/>
           <p:cNvSpPr txBox="1"/>
           <p:nvPr/>
         </p:nvSpPr>
@@ -827,7 +1609,11 @@
               <a:buNone/>
             </a:pPr>
             <a:r>
-              <a:rPr sz="3600" b="1"/>
+              <a:rPr sz="3600" b="1">
+                <a:solidFill>
+                  <a:srgbClr val="7DD3FC"/>
+                </a:solidFill>
+              </a:rPr>
               <a:t>Evaluation Plan</a:t>
             </a:r>
             <a:endParaRPr sz="3600"/>
@@ -836,28 +1622,32 @@
       </p:sp>
       <p:sp>
         <p:nvSpPr>
-          <p:cNvPr id="3" name="Body"/>
-          <p:cNvSpPr txBox="1"/>
-          <p:nvPr/>
-        </p:nvSpPr>
-        <p:spPr>
-          <a:xfrm>
-            <a:off x="685800" y="1143000"/>
-            <a:ext cx="7772400" cy="3429000"/>
-          </a:xfrm>
-          <a:prstGeom prst="rect">
-            <a:avLst/>
-          </a:prstGeom>
-        </p:spPr>
-        <p:txBody>
-          <a:bodyPr wrap="square"/>
-          <a:lstStyle/>
-          <a:p>
-            <a:pPr>
-              <a:buChar char="•"/>
-            </a:pPr>
-            <a:r>
-              <a:rPr sz="2400"/>
+          <p:cNvPr id="5" name="Body"/>
+          <p:cNvSpPr txBox="1"/>
+          <p:nvPr/>
+        </p:nvSpPr>
+        <p:spPr>
+          <a:xfrm>
+            <a:off x="685800" y="1200000"/>
+            <a:ext cx="7772400" cy="3200000"/>
+          </a:xfrm>
+          <a:prstGeom prst="rect">
+            <a:avLst/>
+          </a:prstGeom>
+        </p:spPr>
+        <p:txBody>
+          <a:bodyPr wrap="square"/>
+          <a:lstStyle/>
+          <a:p>
+            <a:pPr>
+              <a:buChar char="•"/>
+            </a:pPr>
+            <a:r>
+              <a:rPr sz="2400">
+                <a:solidFill>
+                  <a:srgbClr val="E2E8F0"/>
+                </a:solidFill>
+              </a:rPr>
               <a:t>Golden sample suite (50 prompts)</a:t>
             </a:r>
             <a:endParaRPr sz="2400"/>
@@ -867,7 +1657,11 @@
               <a:buChar char="•"/>
             </a:pPr>
             <a:r>
-              <a:rPr sz="2400"/>
+              <a:rPr sz="2400">
+                <a:solidFill>
+                  <a:srgbClr val="E2E8F0"/>
+                </a:solidFill>
+              </a:rPr>
               <a:t>HumanEval/MBPP output generation</a:t>
             </a:r>
             <a:endParaRPr sz="2400"/>
@@ -877,10 +1671,48 @@
               <a:buChar char="•"/>
             </a:pPr>
             <a:r>
-              <a:rPr sz="2400"/>
+              <a:rPr sz="2400">
+                <a:solidFill>
+                  <a:srgbClr val="E2E8F0"/>
+                </a:solidFill>
+              </a:rPr>
               <a:t>Full 1MB overfit gate on training hardware</a:t>
             </a:r>
             <a:endParaRPr sz="2400"/>
+          </a:p>
+        </p:txBody>
+      </p:sp>
+      <p:sp>
+        <p:nvSpPr>
+          <p:cNvPr id="6" name="Footer"/>
+          <p:cNvSpPr txBox="1"/>
+          <p:nvPr/>
+        </p:nvSpPr>
+        <p:spPr>
+          <a:xfrm>
+            <a:off x="457200" y="4700000"/>
+            <a:ext cx="8229600" cy="300000"/>
+          </a:xfrm>
+          <a:prstGeom prst="rect">
+            <a:avLst/>
+          </a:prstGeom>
+        </p:spPr>
+        <p:txBody>
+          <a:bodyPr wrap="square"/>
+          <a:lstStyle/>
+          <a:p>
+            <a:pPr>
+              <a:buNone/>
+            </a:pPr>
+            <a:r>
+              <a:rPr sz="1400">
+                <a:solidFill>
+                  <a:srgbClr val="94A3B8"/>
+                </a:solidFill>
+              </a:rPr>
+              <a:t>Confidential — MertFormer Titan</a:t>
+            </a:r>
+            <a:endParaRPr sz="1400"/>
           </a:p>
         </p:txBody>
       </p:sp>
@@ -909,7 +1741,61 @@
       </p:grpSpPr>
       <p:sp>
         <p:nvSpPr>
-          <p:cNvPr id="2" name="Title"/>
+          <p:cNvPr id="2" name="Background"/>
+          <p:cNvSpPr/>
+          <p:nvPr/>
+        </p:nvSpPr>
+        <p:spPr>
+          <a:xfrm>
+            <a:off x="0" y="0"/>
+            <a:ext cx="9144000" cy="5143500"/>
+          </a:xfrm>
+          <a:prstGeom prst="rect">
+            <a:avLst/>
+          </a:prstGeom>
+          <a:solidFill>
+            <a:srgbClr val="0F172A"/>
+          </a:solidFill>
+          <a:ln>
+            <a:noFill/>
+          </a:ln>
+        </p:spPr>
+        <p:txBody>
+          <a:bodyPr/>
+          <a:lstStyle/>
+          <a:p/>
+        </p:txBody>
+      </p:sp>
+      <p:sp>
+        <p:nvSpPr>
+          <p:cNvPr id="3" name="Accent"/>
+          <p:cNvSpPr/>
+          <p:nvPr/>
+        </p:nvSpPr>
+        <p:spPr>
+          <a:xfrm>
+            <a:off x="0" y="0"/>
+            <a:ext cx="9144000" cy="120000"/>
+          </a:xfrm>
+          <a:prstGeom prst="rect">
+            <a:avLst/>
+          </a:prstGeom>
+          <a:solidFill>
+            <a:srgbClr val="22D3EE"/>
+          </a:solidFill>
+          <a:ln>
+            <a:noFill/>
+          </a:ln>
+        </p:spPr>
+        <p:txBody>
+          <a:bodyPr/>
+          <a:lstStyle/>
+          <a:p/>
+        </p:txBody>
+      </p:sp>
+      <p:sp>
+        <p:nvSpPr>
+          <p:cNvPr id="4" name="Title"/>
           <p:cNvSpPr txBox="1"/>
           <p:nvPr/>
         </p:nvSpPr>
@@ -930,7 +1816,11 @@
               <a:buNone/>
             </a:pPr>
             <a:r>
-              <a:rPr sz="3600" b="1"/>
+              <a:rPr sz="3600" b="1">
+                <a:solidFill>
+                  <a:srgbClr val="7DD3FC"/>
+                </a:solidFill>
+              </a:rPr>
               <a:t>Market &amp; Use Cases</a:t>
             </a:r>
             <a:endParaRPr sz="3600"/>
@@ -939,28 +1829,32 @@
       </p:sp>
       <p:sp>
         <p:nvSpPr>
-          <p:cNvPr id="3" name="Body"/>
-          <p:cNvSpPr txBox="1"/>
-          <p:nvPr/>
-        </p:nvSpPr>
-        <p:spPr>
-          <a:xfrm>
-            <a:off x="685800" y="1143000"/>
-            <a:ext cx="7772400" cy="3429000"/>
-          </a:xfrm>
-          <a:prstGeom prst="rect">
-            <a:avLst/>
-          </a:prstGeom>
-        </p:spPr>
-        <p:txBody>
-          <a:bodyPr wrap="square"/>
-          <a:lstStyle/>
-          <a:p>
-            <a:pPr>
-              <a:buChar char="•"/>
-            </a:pPr>
-            <a:r>
-              <a:rPr sz="2400"/>
+          <p:cNvPr id="5" name="Body"/>
+          <p:cNvSpPr txBox="1"/>
+          <p:nvPr/>
+        </p:nvSpPr>
+        <p:spPr>
+          <a:xfrm>
+            <a:off x="685800" y="1200000"/>
+            <a:ext cx="7772400" cy="3200000"/>
+          </a:xfrm>
+          <a:prstGeom prst="rect">
+            <a:avLst/>
+          </a:prstGeom>
+        </p:spPr>
+        <p:txBody>
+          <a:bodyPr wrap="square"/>
+          <a:lstStyle/>
+          <a:p>
+            <a:pPr>
+              <a:buChar char="•"/>
+            </a:pPr>
+            <a:r>
+              <a:rPr sz="2400">
+                <a:solidFill>
+                  <a:srgbClr val="E2E8F0"/>
+                </a:solidFill>
+              </a:rPr>
               <a:t>Regulated enterprises and defense workflows</a:t>
             </a:r>
             <a:endParaRPr sz="2400"/>
@@ -970,7 +1864,11 @@
               <a:buChar char="•"/>
             </a:pPr>
             <a:r>
-              <a:rPr sz="2400"/>
+              <a:rPr sz="2400">
+                <a:solidFill>
+                  <a:srgbClr val="E2E8F0"/>
+                </a:solidFill>
+              </a:rPr>
               <a:t>On-device copilots for low-connectivity regions</a:t>
             </a:r>
             <a:endParaRPr sz="2400"/>
@@ -980,10 +1878,48 @@
               <a:buChar char="•"/>
             </a:pPr>
             <a:r>
-              <a:rPr sz="2400"/>
+              <a:rPr sz="2400">
+                <a:solidFill>
+                  <a:srgbClr val="E2E8F0"/>
+                </a:solidFill>
+              </a:rPr>
               <a:t>Private inference stacks with data control</a:t>
             </a:r>
             <a:endParaRPr sz="2400"/>
+          </a:p>
+        </p:txBody>
+      </p:sp>
+      <p:sp>
+        <p:nvSpPr>
+          <p:cNvPr id="6" name="Footer"/>
+          <p:cNvSpPr txBox="1"/>
+          <p:nvPr/>
+        </p:nvSpPr>
+        <p:spPr>
+          <a:xfrm>
+            <a:off x="457200" y="4700000"/>
+            <a:ext cx="8229600" cy="300000"/>
+          </a:xfrm>
+          <a:prstGeom prst="rect">
+            <a:avLst/>
+          </a:prstGeom>
+        </p:spPr>
+        <p:txBody>
+          <a:bodyPr wrap="square"/>
+          <a:lstStyle/>
+          <a:p>
+            <a:pPr>
+              <a:buNone/>
+            </a:pPr>
+            <a:r>
+              <a:rPr sz="1400">
+                <a:solidFill>
+                  <a:srgbClr val="94A3B8"/>
+                </a:solidFill>
+              </a:rPr>
+              <a:t>Confidential — MertFormer Titan</a:t>
+            </a:r>
+            <a:endParaRPr sz="1400"/>
           </a:p>
         </p:txBody>
       </p:sp>
@@ -1012,7 +1948,61 @@
       </p:grpSpPr>
       <p:sp>
         <p:nvSpPr>
-          <p:cNvPr id="2" name="Title"/>
+          <p:cNvPr id="2" name="Background"/>
+          <p:cNvSpPr/>
+          <p:nvPr/>
+        </p:nvSpPr>
+        <p:spPr>
+          <a:xfrm>
+            <a:off x="0" y="0"/>
+            <a:ext cx="9144000" cy="5143500"/>
+          </a:xfrm>
+          <a:prstGeom prst="rect">
+            <a:avLst/>
+          </a:prstGeom>
+          <a:solidFill>
+            <a:srgbClr val="0F172A"/>
+          </a:solidFill>
+          <a:ln>
+            <a:noFill/>
+          </a:ln>
+        </p:spPr>
+        <p:txBody>
+          <a:bodyPr/>
+          <a:lstStyle/>
+          <a:p/>
+        </p:txBody>
+      </p:sp>
+      <p:sp>
+        <p:nvSpPr>
+          <p:cNvPr id="3" name="Accent"/>
+          <p:cNvSpPr/>
+          <p:nvPr/>
+        </p:nvSpPr>
+        <p:spPr>
+          <a:xfrm>
+            <a:off x="0" y="0"/>
+            <a:ext cx="9144000" cy="120000"/>
+          </a:xfrm>
+          <a:prstGeom prst="rect">
+            <a:avLst/>
+          </a:prstGeom>
+          <a:solidFill>
+            <a:srgbClr val="22D3EE"/>
+          </a:solidFill>
+          <a:ln>
+            <a:noFill/>
+          </a:ln>
+        </p:spPr>
+        <p:txBody>
+          <a:bodyPr/>
+          <a:lstStyle/>
+          <a:p/>
+        </p:txBody>
+      </p:sp>
+      <p:sp>
+        <p:nvSpPr>
+          <p:cNvPr id="4" name="Title"/>
           <p:cNvSpPr txBox="1"/>
           <p:nvPr/>
         </p:nvSpPr>
@@ -1033,7 +2023,11 @@
               <a:buNone/>
             </a:pPr>
             <a:r>
-              <a:rPr sz="3600" b="1"/>
+              <a:rPr sz="3600" b="1">
+                <a:solidFill>
+                  <a:srgbClr val="7DD3FC"/>
+                </a:solidFill>
+              </a:rPr>
               <a:t>Roadmap</a:t>
             </a:r>
             <a:endParaRPr sz="3600"/>
@@ -1042,28 +2036,32 @@
       </p:sp>
       <p:sp>
         <p:nvSpPr>
-          <p:cNvPr id="3" name="Body"/>
-          <p:cNvSpPr txBox="1"/>
-          <p:nvPr/>
-        </p:nvSpPr>
-        <p:spPr>
-          <a:xfrm>
-            <a:off x="685800" y="1143000"/>
-            <a:ext cx="7772400" cy="3429000"/>
-          </a:xfrm>
-          <a:prstGeom prst="rect">
-            <a:avLst/>
-          </a:prstGeom>
-        </p:spPr>
-        <p:txBody>
-          <a:bodyPr wrap="square"/>
-          <a:lstStyle/>
-          <a:p>
-            <a:pPr>
-              <a:buChar char="•"/>
-            </a:pPr>
-            <a:r>
-              <a:rPr sz="2400"/>
+          <p:cNvPr id="5" name="Body"/>
+          <p:cNvSpPr txBox="1"/>
+          <p:nvPr/>
+        </p:nvSpPr>
+        <p:spPr>
+          <a:xfrm>
+            <a:off x="685800" y="1200000"/>
+            <a:ext cx="7772400" cy="3200000"/>
+          </a:xfrm>
+          <a:prstGeom prst="rect">
+            <a:avLst/>
+          </a:prstGeom>
+        </p:spPr>
+        <p:txBody>
+          <a:bodyPr wrap="square"/>
+          <a:lstStyle/>
+          <a:p>
+            <a:pPr>
+              <a:buChar char="•"/>
+            </a:pPr>
+            <a:r>
+              <a:rPr sz="2400">
+                <a:solidFill>
+                  <a:srgbClr val="E2E8F0"/>
+                </a:solidFill>
+              </a:rPr>
               <a:t>Master run (2.6B) with telemetry gates</a:t>
             </a:r>
             <a:endParaRPr sz="2400"/>
@@ -1073,7 +2071,11 @@
               <a:buChar char="•"/>
             </a:pPr>
             <a:r>
-              <a:rPr sz="2400"/>
+              <a:rPr sz="2400">
+                <a:solidFill>
+                  <a:srgbClr val="E2E8F0"/>
+                </a:solidFill>
+              </a:rPr>
               <a:t>Benchmark validation + pilot deployments</a:t>
             </a:r>
             <a:endParaRPr sz="2400"/>
@@ -1083,10 +2085,48 @@
               <a:buChar char="•"/>
             </a:pPr>
             <a:r>
-              <a:rPr sz="2400"/>
+              <a:rPr sz="2400">
+                <a:solidFill>
+                  <a:srgbClr val="E2E8F0"/>
+                </a:solidFill>
+              </a:rPr>
               <a:t>Asset stack + demo video for launch</a:t>
             </a:r>
             <a:endParaRPr sz="2400"/>
+          </a:p>
+        </p:txBody>
+      </p:sp>
+      <p:sp>
+        <p:nvSpPr>
+          <p:cNvPr id="6" name="Footer"/>
+          <p:cNvSpPr txBox="1"/>
+          <p:nvPr/>
+        </p:nvSpPr>
+        <p:spPr>
+          <a:xfrm>
+            <a:off x="457200" y="4700000"/>
+            <a:ext cx="8229600" cy="300000"/>
+          </a:xfrm>
+          <a:prstGeom prst="rect">
+            <a:avLst/>
+          </a:prstGeom>
+        </p:spPr>
+        <p:txBody>
+          <a:bodyPr wrap="square"/>
+          <a:lstStyle/>
+          <a:p>
+            <a:pPr>
+              <a:buNone/>
+            </a:pPr>
+            <a:r>
+              <a:rPr sz="1400">
+                <a:solidFill>
+                  <a:srgbClr val="94A3B8"/>
+                </a:solidFill>
+              </a:rPr>
+              <a:t>Confidential — MertFormer Titan</a:t>
+            </a:r>
+            <a:endParaRPr sz="1400"/>
           </a:p>
         </p:txBody>
       </p:sp>
@@ -1099,44 +2139,44 @@
 </file>
 
 <file path=ppt/theme/theme1.xml><?xml version="1.0" encoding="utf-8"?>
-<a:theme xmlns:a="http://schemas.openxmlformats.org/drawingml/2006/main" name="Office Theme">
+<a:theme xmlns:a="http://schemas.openxmlformats.org/drawingml/2006/main" name="MertFormer Theme">
   <a:themeElements>
-    <a:clrScheme name="Office">
+    <a:clrScheme name="MertFormer">
       <a:dk1>
-        <a:sysClr val="windowText" lastClr="000000"/>
+        <a:srgbClr val="000000"/>
       </a:dk1>
       <a:lt1>
-        <a:sysClr val="window" lastClr="FFFFFF"/>
+        <a:srgbClr val="FFFFFF"/>
       </a:lt1>
       <a:dk2>
-        <a:srgbClr val="1F1F1F"/>
+        <a:srgbClr val="1E293B"/>
       </a:dk2>
       <a:lt2>
-        <a:srgbClr val="EEEEEE"/>
+        <a:srgbClr val="E2E8F0"/>
       </a:lt2>
       <a:accent1>
-        <a:srgbClr val="4F81BD"/>
+        <a:srgbClr val="22D3EE"/>
       </a:accent1>
       <a:accent2>
-        <a:srgbClr val="C0504D"/>
+        <a:srgbClr val="7DD3FC"/>
       </a:accent2>
       <a:accent3>
-        <a:srgbClr val="9BBB59"/>
+        <a:srgbClr val="94A3B8"/>
       </a:accent3>
       <a:accent4>
-        <a:srgbClr val="8064A2"/>
+        <a:srgbClr val="38BDF8"/>
       </a:accent4>
       <a:accent5>
-        <a:srgbClr val="4BACC6"/>
+        <a:srgbClr val="0EA5E9"/>
       </a:accent5>
       <a:accent6>
-        <a:srgbClr val="F79646"/>
+        <a:srgbClr val="22C55E"/>
       </a:accent6>
       <a:hlink>
-        <a:srgbClr val="0000FF"/>
+        <a:srgbClr val="0EA5E9"/>
       </a:hlink>
       <a:folHlink>
-        <a:srgbClr val="800080"/>
+        <a:srgbClr val="64748B"/>
       </a:folHlink>
     </a:clrScheme>
     <a:fontScheme name="Office">
@@ -1147,14 +2187,7 @@
         <a:latin typeface="Calibri"/>
       </a:minorFont>
     </a:fontScheme>
-    <a:fmtScheme name="Office">
-      <a:fillStyleLst/>
-      <a:lnStyleLst/>
-      <a:effectStyleLst/>
-      <a:bgFillStyleLst/>
-    </a:fmtScheme>
+    <a:fmtScheme name="Office"/>
   </a:themeElements>
-  <a:objectDefaults/>
-  <a:extraClrSchemeLst/>
 </a:theme>
 </file>
</xml_diff>

<commit_message>
docs: add compute and pilot slides
</commit_message>
<xml_diff>
--- a/reports/investor_deck.pptx
+++ b/reports/investor_deck.pptx
@@ -15,6 +15,8 @@
     <p:sldId id="263" r:id="rId9"/>
     <p:sldId id="264" r:id="rId10"/>
     <p:sldId id="265" r:id="rId11"/>
+    <p:sldId id="266" r:id="rId12"/>
+    <p:sldId id="267" r:id="rId13"/>
   </p:sldIdLst>
   <p:sldSz cx="9144000" cy="5143500" type="screen16x9"/>
   <p:notesSz cx="6858000" cy="9144000"/>
@@ -372,6 +374,420 @@
                   <a:srgbClr val="7DD3FC"/>
                 </a:solidFill>
               </a:rPr>
+              <a:t>Market &amp; Use Cases</a:t>
+            </a:r>
+            <a:endParaRPr sz="3600"/>
+          </a:p>
+        </p:txBody>
+      </p:sp>
+      <p:sp>
+        <p:nvSpPr>
+          <p:cNvPr id="5" name="Body"/>
+          <p:cNvSpPr txBox="1"/>
+          <p:nvPr/>
+        </p:nvSpPr>
+        <p:spPr>
+          <a:xfrm>
+            <a:off x="685800" y="1200000"/>
+            <a:ext cx="7772400" cy="3200000"/>
+          </a:xfrm>
+          <a:prstGeom prst="rect">
+            <a:avLst/>
+          </a:prstGeom>
+        </p:spPr>
+        <p:txBody>
+          <a:bodyPr wrap="square"/>
+          <a:lstStyle/>
+          <a:p>
+            <a:pPr>
+              <a:buChar char="•"/>
+            </a:pPr>
+            <a:r>
+              <a:rPr sz="2400">
+                <a:solidFill>
+                  <a:srgbClr val="E2E8F0"/>
+                </a:solidFill>
+              </a:rPr>
+              <a:t>Regulated enterprises and defense workflows</a:t>
+            </a:r>
+            <a:endParaRPr sz="2400"/>
+          </a:p>
+          <a:p>
+            <a:pPr>
+              <a:buChar char="•"/>
+            </a:pPr>
+            <a:r>
+              <a:rPr sz="2400">
+                <a:solidFill>
+                  <a:srgbClr val="E2E8F0"/>
+                </a:solidFill>
+              </a:rPr>
+              <a:t>On-device copilots for low-connectivity regions</a:t>
+            </a:r>
+            <a:endParaRPr sz="2400"/>
+          </a:p>
+          <a:p>
+            <a:pPr>
+              <a:buChar char="•"/>
+            </a:pPr>
+            <a:r>
+              <a:rPr sz="2400">
+                <a:solidFill>
+                  <a:srgbClr val="E2E8F0"/>
+                </a:solidFill>
+              </a:rPr>
+              <a:t>Private inference stacks with data control</a:t>
+            </a:r>
+            <a:endParaRPr sz="2400"/>
+          </a:p>
+        </p:txBody>
+      </p:sp>
+      <p:sp>
+        <p:nvSpPr>
+          <p:cNvPr id="6" name="Footer"/>
+          <p:cNvSpPr txBox="1"/>
+          <p:nvPr/>
+        </p:nvSpPr>
+        <p:spPr>
+          <a:xfrm>
+            <a:off x="457200" y="4700000"/>
+            <a:ext cx="8229600" cy="300000"/>
+          </a:xfrm>
+          <a:prstGeom prst="rect">
+            <a:avLst/>
+          </a:prstGeom>
+        </p:spPr>
+        <p:txBody>
+          <a:bodyPr wrap="square"/>
+          <a:lstStyle/>
+          <a:p>
+            <a:pPr>
+              <a:buNone/>
+            </a:pPr>
+            <a:r>
+              <a:rPr sz="1400">
+                <a:solidFill>
+                  <a:srgbClr val="94A3B8"/>
+                </a:solidFill>
+              </a:rPr>
+              <a:t>Confidential — MertFormer Titan</a:t>
+            </a:r>
+            <a:endParaRPr sz="1400"/>
+          </a:p>
+        </p:txBody>
+      </p:sp>
+    </p:spTree>
+  </p:cSld>
+  <p:clrMapOvr>
+    <a:masterClrMapping/>
+  </p:clrMapOvr>
+</p:sld>
+</file>
+
+<file path=ppt/slides/slide11.xml><?xml version="1.0" encoding="utf-8"?>
+<p:sld xmlns:p="http://schemas.openxmlformats.org/presentationml/2006/main" xmlns:a="http://schemas.openxmlformats.org/drawingml/2006/main" xmlns:r="http://schemas.openxmlformats.org/officeDocument/2006/relationships">
+  <p:cSld>
+    <p:spTree>
+      <p:nvGrpSpPr>
+        <p:cNvPr id="1" name=""/>
+        <p:cNvGrpSpPr/>
+        <p:nvPr/>
+      </p:nvGrpSpPr>
+      <p:grpSpPr>
+        <a:xfrm>
+          <a:off x="0" y="0"/>
+          <a:ext cx="0" cy="0"/>
+        </a:xfrm>
+      </p:grpSpPr>
+      <p:sp>
+        <p:nvSpPr>
+          <p:cNvPr id="2" name="Background"/>
+          <p:cNvSpPr/>
+          <p:nvPr/>
+        </p:nvSpPr>
+        <p:spPr>
+          <a:xfrm>
+            <a:off x="0" y="0"/>
+            <a:ext cx="9144000" cy="5143500"/>
+          </a:xfrm>
+          <a:prstGeom prst="rect">
+            <a:avLst/>
+          </a:prstGeom>
+          <a:solidFill>
+            <a:srgbClr val="0F172A"/>
+          </a:solidFill>
+          <a:ln>
+            <a:noFill/>
+          </a:ln>
+        </p:spPr>
+        <p:txBody>
+          <a:bodyPr/>
+          <a:lstStyle/>
+          <a:p/>
+        </p:txBody>
+      </p:sp>
+      <p:sp>
+        <p:nvSpPr>
+          <p:cNvPr id="3" name="Accent"/>
+          <p:cNvSpPr/>
+          <p:nvPr/>
+        </p:nvSpPr>
+        <p:spPr>
+          <a:xfrm>
+            <a:off x="0" y="0"/>
+            <a:ext cx="9144000" cy="120000"/>
+          </a:xfrm>
+          <a:prstGeom prst="rect">
+            <a:avLst/>
+          </a:prstGeom>
+          <a:solidFill>
+            <a:srgbClr val="22D3EE"/>
+          </a:solidFill>
+          <a:ln>
+            <a:noFill/>
+          </a:ln>
+        </p:spPr>
+        <p:txBody>
+          <a:bodyPr/>
+          <a:lstStyle/>
+          <a:p/>
+        </p:txBody>
+      </p:sp>
+      <p:sp>
+        <p:nvSpPr>
+          <p:cNvPr id="4" name="Title"/>
+          <p:cNvSpPr txBox="1"/>
+          <p:nvPr/>
+        </p:nvSpPr>
+        <p:spPr>
+          <a:xfrm>
+            <a:off x="457200" y="228600"/>
+            <a:ext cx="8229600" cy="685800"/>
+          </a:xfrm>
+          <a:prstGeom prst="rect">
+            <a:avLst/>
+          </a:prstGeom>
+        </p:spPr>
+        <p:txBody>
+          <a:bodyPr wrap="square"/>
+          <a:lstStyle/>
+          <a:p>
+            <a:pPr>
+              <a:buNone/>
+            </a:pPr>
+            <a:r>
+              <a:rPr sz="3600" b="1">
+                <a:solidFill>
+                  <a:srgbClr val="7DD3FC"/>
+                </a:solidFill>
+              </a:rPr>
+              <a:t>Roadmap</a:t>
+            </a:r>
+            <a:endParaRPr sz="3600"/>
+          </a:p>
+        </p:txBody>
+      </p:sp>
+      <p:sp>
+        <p:nvSpPr>
+          <p:cNvPr id="5" name="Body"/>
+          <p:cNvSpPr txBox="1"/>
+          <p:nvPr/>
+        </p:nvSpPr>
+        <p:spPr>
+          <a:xfrm>
+            <a:off x="685800" y="1200000"/>
+            <a:ext cx="7772400" cy="3200000"/>
+          </a:xfrm>
+          <a:prstGeom prst="rect">
+            <a:avLst/>
+          </a:prstGeom>
+        </p:spPr>
+        <p:txBody>
+          <a:bodyPr wrap="square"/>
+          <a:lstStyle/>
+          <a:p>
+            <a:pPr>
+              <a:buChar char="•"/>
+            </a:pPr>
+            <a:r>
+              <a:rPr sz="2400">
+                <a:solidFill>
+                  <a:srgbClr val="E2E8F0"/>
+                </a:solidFill>
+              </a:rPr>
+              <a:t>Master run (2.6B) with telemetry gates</a:t>
+            </a:r>
+            <a:endParaRPr sz="2400"/>
+          </a:p>
+          <a:p>
+            <a:pPr>
+              <a:buChar char="•"/>
+            </a:pPr>
+            <a:r>
+              <a:rPr sz="2400">
+                <a:solidFill>
+                  <a:srgbClr val="E2E8F0"/>
+                </a:solidFill>
+              </a:rPr>
+              <a:t>Benchmark validation + pilot deployments</a:t>
+            </a:r>
+            <a:endParaRPr sz="2400"/>
+          </a:p>
+          <a:p>
+            <a:pPr>
+              <a:buChar char="•"/>
+            </a:pPr>
+            <a:r>
+              <a:rPr sz="2400">
+                <a:solidFill>
+                  <a:srgbClr val="E2E8F0"/>
+                </a:solidFill>
+              </a:rPr>
+              <a:t>Asset stack + demo video for launch</a:t>
+            </a:r>
+            <a:endParaRPr sz="2400"/>
+          </a:p>
+        </p:txBody>
+      </p:sp>
+      <p:sp>
+        <p:nvSpPr>
+          <p:cNvPr id="6" name="Footer"/>
+          <p:cNvSpPr txBox="1"/>
+          <p:nvPr/>
+        </p:nvSpPr>
+        <p:spPr>
+          <a:xfrm>
+            <a:off x="457200" y="4700000"/>
+            <a:ext cx="8229600" cy="300000"/>
+          </a:xfrm>
+          <a:prstGeom prst="rect">
+            <a:avLst/>
+          </a:prstGeom>
+        </p:spPr>
+        <p:txBody>
+          <a:bodyPr wrap="square"/>
+          <a:lstStyle/>
+          <a:p>
+            <a:pPr>
+              <a:buNone/>
+            </a:pPr>
+            <a:r>
+              <a:rPr sz="1400">
+                <a:solidFill>
+                  <a:srgbClr val="94A3B8"/>
+                </a:solidFill>
+              </a:rPr>
+              <a:t>Confidential — MertFormer Titan</a:t>
+            </a:r>
+            <a:endParaRPr sz="1400"/>
+          </a:p>
+        </p:txBody>
+      </p:sp>
+    </p:spTree>
+  </p:cSld>
+  <p:clrMapOvr>
+    <a:masterClrMapping/>
+  </p:clrMapOvr>
+</p:sld>
+</file>
+
+<file path=ppt/slides/slide12.xml><?xml version="1.0" encoding="utf-8"?>
+<p:sld xmlns:p="http://schemas.openxmlformats.org/presentationml/2006/main" xmlns:a="http://schemas.openxmlformats.org/drawingml/2006/main" xmlns:r="http://schemas.openxmlformats.org/officeDocument/2006/relationships">
+  <p:cSld>
+    <p:spTree>
+      <p:nvGrpSpPr>
+        <p:cNvPr id="1" name=""/>
+        <p:cNvGrpSpPr/>
+        <p:nvPr/>
+      </p:nvGrpSpPr>
+      <p:grpSpPr>
+        <a:xfrm>
+          <a:off x="0" y="0"/>
+          <a:ext cx="0" cy="0"/>
+        </a:xfrm>
+      </p:grpSpPr>
+      <p:sp>
+        <p:nvSpPr>
+          <p:cNvPr id="2" name="Background"/>
+          <p:cNvSpPr/>
+          <p:nvPr/>
+        </p:nvSpPr>
+        <p:spPr>
+          <a:xfrm>
+            <a:off x="0" y="0"/>
+            <a:ext cx="9144000" cy="5143500"/>
+          </a:xfrm>
+          <a:prstGeom prst="rect">
+            <a:avLst/>
+          </a:prstGeom>
+          <a:solidFill>
+            <a:srgbClr val="0F172A"/>
+          </a:solidFill>
+          <a:ln>
+            <a:noFill/>
+          </a:ln>
+        </p:spPr>
+        <p:txBody>
+          <a:bodyPr/>
+          <a:lstStyle/>
+          <a:p/>
+        </p:txBody>
+      </p:sp>
+      <p:sp>
+        <p:nvSpPr>
+          <p:cNvPr id="3" name="Accent"/>
+          <p:cNvSpPr/>
+          <p:nvPr/>
+        </p:nvSpPr>
+        <p:spPr>
+          <a:xfrm>
+            <a:off x="0" y="0"/>
+            <a:ext cx="9144000" cy="120000"/>
+          </a:xfrm>
+          <a:prstGeom prst="rect">
+            <a:avLst/>
+          </a:prstGeom>
+          <a:solidFill>
+            <a:srgbClr val="22D3EE"/>
+          </a:solidFill>
+          <a:ln>
+            <a:noFill/>
+          </a:ln>
+        </p:spPr>
+        <p:txBody>
+          <a:bodyPr/>
+          <a:lstStyle/>
+          <a:p/>
+        </p:txBody>
+      </p:sp>
+      <p:sp>
+        <p:nvSpPr>
+          <p:cNvPr id="4" name="Title"/>
+          <p:cNvSpPr txBox="1"/>
+          <p:nvPr/>
+        </p:nvSpPr>
+        <p:spPr>
+          <a:xfrm>
+            <a:off x="457200" y="228600"/>
+            <a:ext cx="8229600" cy="685800"/>
+          </a:xfrm>
+          <a:prstGeom prst="rect">
+            <a:avLst/>
+          </a:prstGeom>
+        </p:spPr>
+        <p:txBody>
+          <a:bodyPr wrap="square"/>
+          <a:lstStyle/>
+          <a:p>
+            <a:pPr>
+              <a:buNone/>
+            </a:pPr>
+            <a:r>
+              <a:rPr sz="3600" b="1">
+                <a:solidFill>
+                  <a:srgbClr val="7DD3FC"/>
+                </a:solidFill>
+              </a:rPr>
               <a:t>Ask</a:t>
             </a:r>
             <a:endParaRPr sz="3600"/>
@@ -1821,7 +2237,7 @@
                   <a:srgbClr val="7DD3FC"/>
                 </a:solidFill>
               </a:rPr>
-              <a:t>Market &amp; Use Cases</a:t>
+              <a:t>Compute Need &amp; Plan</a:t>
             </a:r>
             <a:endParaRPr sz="3600"/>
           </a:p>
@@ -1855,35 +2271,35 @@
                   <a:srgbClr val="E2E8F0"/>
                 </a:solidFill>
               </a:rPr>
-              <a:t>Regulated enterprises and defense workflows</a:t>
-            </a:r>
-            <a:endParaRPr sz="2400"/>
-          </a:p>
-          <a:p>
-            <a:pPr>
-              <a:buChar char="•"/>
-            </a:pPr>
-            <a:r>
-              <a:rPr sz="2400">
-                <a:solidFill>
-                  <a:srgbClr val="E2E8F0"/>
-                </a:solidFill>
-              </a:rPr>
-              <a:t>On-device copilots for low-connectivity regions</a:t>
-            </a:r>
-            <a:endParaRPr sz="2400"/>
-          </a:p>
-          <a:p>
-            <a:pPr>
-              <a:buChar char="•"/>
-            </a:pPr>
-            <a:r>
-              <a:rPr sz="2400">
-                <a:solidFill>
-                  <a:srgbClr val="E2E8F0"/>
-                </a:solidFill>
-              </a:rPr>
-              <a:t>Private inference stacks with data control</a:t>
+              <a:t>Multi-GPU credits for master run (A100/H100 class)</a:t>
+            </a:r>
+            <a:endParaRPr sz="2400"/>
+          </a:p>
+          <a:p>
+            <a:pPr>
+              <a:buChar char="•"/>
+            </a:pPr>
+            <a:r>
+              <a:rPr sz="2400">
+                <a:solidFill>
+                  <a:srgbClr val="E2E8F0"/>
+                </a:solidFill>
+              </a:rPr>
+              <a:t>Phased run: full 1MB gate → master run → benchmarks</a:t>
+            </a:r>
+            <a:endParaRPr sz="2400"/>
+          </a:p>
+          <a:p>
+            <a:pPr>
+              <a:buChar char="•"/>
+            </a:pPr>
+            <a:r>
+              <a:rPr sz="2400">
+                <a:solidFill>
+                  <a:srgbClr val="E2E8F0"/>
+                </a:solidFill>
+              </a:rPr>
+              <a:t>Deliverables: checkpoints, logs, eval outputs</a:t>
             </a:r>
             <a:endParaRPr sz="2400"/>
           </a:p>
@@ -2028,7 +2444,7 @@
                   <a:srgbClr val="7DD3FC"/>
                 </a:solidFill>
               </a:rPr>
-              <a:t>Roadmap</a:t>
+              <a:t>Pilot / Go-to-Market</a:t>
             </a:r>
             <a:endParaRPr sz="3600"/>
           </a:p>
@@ -2062,35 +2478,35 @@
                   <a:srgbClr val="E2E8F0"/>
                 </a:solidFill>
               </a:rPr>
-              <a:t>Master run (2.6B) with telemetry gates</a:t>
-            </a:r>
-            <a:endParaRPr sz="2400"/>
-          </a:p>
-          <a:p>
-            <a:pPr>
-              <a:buChar char="•"/>
-            </a:pPr>
-            <a:r>
-              <a:rPr sz="2400">
-                <a:solidFill>
-                  <a:srgbClr val="E2E8F0"/>
-                </a:solidFill>
-              </a:rPr>
-              <a:t>Benchmark validation + pilot deployments</a:t>
-            </a:r>
-            <a:endParaRPr sz="2400"/>
-          </a:p>
-          <a:p>
-            <a:pPr>
-              <a:buChar char="•"/>
-            </a:pPr>
-            <a:r>
-              <a:rPr sz="2400">
-                <a:solidFill>
-                  <a:srgbClr val="E2E8F0"/>
-                </a:solidFill>
-              </a:rPr>
-              <a:t>Asset stack + demo video for launch</a:t>
+              <a:t>Offline PoC for regulated teams (defense/legal/finance)</a:t>
+            </a:r>
+            <a:endParaRPr sz="2400"/>
+          </a:p>
+          <a:p>
+            <a:pPr>
+              <a:buChar char="•"/>
+            </a:pPr>
+            <a:r>
+              <a:rPr sz="2400">
+                <a:solidFill>
+                  <a:srgbClr val="E2E8F0"/>
+                </a:solidFill>
+              </a:rPr>
+              <a:t>2–4 week pilot with clear success criteria</a:t>
+            </a:r>
+            <a:endParaRPr sz="2400"/>
+          </a:p>
+          <a:p>
+            <a:pPr>
+              <a:buChar char="•"/>
+            </a:pPr>
+            <a:r>
+              <a:rPr sz="2400">
+                <a:solidFill>
+                  <a:srgbClr val="E2E8F0"/>
+                </a:solidFill>
+              </a:rPr>
+              <a:t>Post‑pilot: paid deployments + support</a:t>
             </a:r>
             <a:endParaRPr sz="2400"/>
           </a:p>

</xml_diff>

<commit_message>
docs(deck): add SDK mention
</commit_message>
<xml_diff>
--- a/reports/investor_deck.pptx
+++ b/reports/investor_deck.pptx
@@ -1475,6 +1475,20 @@
             </a:r>
             <a:endParaRPr sz="2400"/>
           </a:p>
+          <a:p>
+            <a:pPr>
+              <a:buChar char="•"/>
+            </a:pPr>
+            <a:r>
+              <a:rPr sz="2400">
+                <a:solidFill>
+                  <a:srgbClr val="E2E8F0"/>
+                </a:solidFill>
+              </a:rPr>
+              <a:t>SDK + CLI for edge deployments</a:t>
+            </a:r>
+            <a:endParaRPr sz="2400"/>
+          </a:p>
         </p:txBody>
       </p:sp>
       <p:sp>

</xml_diff>

<commit_message>
docs(release): align claim-boundary docs and deck; refresh package hashes
</commit_message>
<xml_diff>
--- a/reports/investor_deck.pptx
+++ b/reports/investor_deck.pptx
@@ -201,7 +201,7 @@
                   <a:srgbClr val="E2E8F0"/>
                 </a:solidFill>
               </a:rPr>
-              <a:t>Edge-native coding model (2.6B target)</a:t>
+              <a:t>Edge-native coding model (2.64B target)</a:t>
             </a:r>
             <a:endParaRPr sz="2400"/>
           </a:p>
@@ -615,7 +615,7 @@
                   <a:srgbClr val="E2E8F0"/>
                 </a:solidFill>
               </a:rPr>
-              <a:t>Master run (2.6B) with telemetry gates</a:t>
+              <a:t>Master run (2.64B) with telemetry gates</a:t>
             </a:r>
             <a:endParaRPr sz="2400"/>
           </a:p>
@@ -1443,7 +1443,7 @@
                   <a:srgbClr val="E2E8F0"/>
                 </a:solidFill>
               </a:rPr>
-              <a:t>2.6B parameter target model for coding</a:t>
+              <a:t>2.64B parameter target model for coding</a:t>
             </a:r>
             <a:endParaRPr sz="2400"/>
           </a:p>

</xml_diff>

<commit_message>
docs(release): finalize build30 closure package and audits
</commit_message>
<xml_diff>
--- a/reports/investor_deck.pptx
+++ b/reports/investor_deck.pptx
@@ -201,7 +201,21 @@
                   <a:srgbClr val="E2E8F0"/>
                 </a:solidFill>
               </a:rPr>
-              <a:t>Edge-native coding model (2.64B target)</a:t>
+              <a:t>Edge-native coding model (2.64B design target)</a:t>
+            </a:r>
+            <a:endParaRPr sz="2400"/>
+          </a:p>
+          <a:p>
+            <a:pPr>
+              <a:buChar char="•"/>
+            </a:pPr>
+            <a:r>
+              <a:rPr sz="2400">
+                <a:solidFill>
+                  <a:srgbClr val="E2E8F0"/>
+                </a:solidFill>
+              </a:rPr>
+              <a:t>Current build runtime total: ~3.70B</a:t>
             </a:r>
             <a:endParaRPr sz="2400"/>
           </a:p>
@@ -615,7 +629,7 @@
                   <a:srgbClr val="E2E8F0"/>
                 </a:solidFill>
               </a:rPr>
-              <a:t>Master run (2.64B) with telemetry gates</a:t>
+              <a:t>Master run (2.64B design target) with telemetry gates</a:t>
             </a:r>
             <a:endParaRPr sz="2400"/>
           </a:p>
@@ -1443,7 +1457,7 @@
                   <a:srgbClr val="E2E8F0"/>
                 </a:solidFill>
               </a:rPr>
-              <a:t>2.64B parameter target model for coding</a:t>
+              <a:t>2.64B design-target model for coding</a:t>
             </a:r>
             <a:endParaRPr sz="2400"/>
           </a:p>

</xml_diff>

<commit_message>
docs: legal, citation, and deck updates
</commit_message>
<xml_diff>
--- a/reports/investor_deck.pptx
+++ b/reports/investor_deck.pptx
@@ -17,6 +17,7 @@
     <p:sldId id="265" r:id="rId11"/>
     <p:sldId id="266" r:id="rId12"/>
     <p:sldId id="267" r:id="rId13"/>
+    <p:sldId id="268" r:id="rId14"/>
   </p:sldIdLst>
   <p:sldSz cx="9144000" cy="5143500" type="screen16x9"/>
   <p:notesSz cx="6858000" cy="9144000"/>
@@ -912,6 +913,76 @@
 </p:sld>
 </file>
 
+<file path=ppt/slides/slide13.xml><?xml version="1.0" encoding="utf-8"?>
+<p:sld xmlns:a="http://schemas.openxmlformats.org/drawingml/2006/main" xmlns:p="http://schemas.openxmlformats.org/presentationml/2006/main" xmlns:r="http://schemas.openxmlformats.org/officeDocument/2006/relationships">
+  <p:cSld>
+    <p:spTree>
+      <p:nvGrpSpPr>
+        <p:cNvPr id="1" name=""/>
+        <p:cNvGrpSpPr/>
+        <p:nvPr/>
+      </p:nvGrpSpPr>
+      <p:grpSpPr/>
+      <p:sp>
+        <p:nvSpPr>
+          <p:cNvPr id="2" name="TextBox 1"/>
+          <p:cNvSpPr txBox="1"/>
+          <p:nvPr/>
+        </p:nvSpPr>
+        <p:spPr>
+          <a:xfrm>
+            <a:off x="548640" y="365760"/>
+            <a:ext cx="10972800" cy="731520"/>
+          </a:xfrm>
+          <a:prstGeom prst="rect">
+            <a:avLst/>
+          </a:prstGeom>
+          <a:noFill/>
+        </p:spPr>
+        <p:txBody>
+          <a:bodyPr wrap="none">
+            <a:spAutoFit/>
+          </a:bodyPr>
+          <a:lstStyle/>
+          <a:p>
+            <a:r>
+              <a:t>Dedup pipeline enabled (global/stage scope)</a:t>
+            </a:r>
+          </a:p>
+          <a:p>
+            <a:pPr/>
+            <a:r>
+              <a:t>MoE parallel dispatch path (sequential fallback retained)</a:t>
+            </a:r>
+          </a:p>
+          <a:p>
+            <a:pPr/>
+            <a:r>
+              <a:t>Liquid/CfC fast-path opt-in for runtime efficiency</a:t>
+            </a:r>
+          </a:p>
+          <a:p>
+            <a:pPr/>
+            <a:r>
+              <a:t>Training gates + SOP evidence hardened</a:t>
+            </a:r>
+          </a:p>
+          <a:p>
+            <a:pPr/>
+            <a:r>
+              <a:t>Claim boundary unchanged (pre-training, no benchmark claims)</a:t>
+            </a:r>
+          </a:p>
+        </p:txBody>
+      </p:sp>
+    </p:spTree>
+  </p:cSld>
+  <p:clrMapOvr>
+    <a:masterClrMapping/>
+  </p:clrMapOvr>
+</p:sld>
+</file>
+
 <file path=ppt/slides/slide2.xml><?xml version="1.0" encoding="utf-8"?>
 <p:sld xmlns:p="http://schemas.openxmlformats.org/presentationml/2006/main" xmlns:a="http://schemas.openxmlformats.org/drawingml/2006/main" xmlns:r="http://schemas.openxmlformats.org/officeDocument/2006/relationships">
   <p:cSld>

</xml_diff>